<commit_message>
docs(presentations): verify viewer rendering and reproducible deck
</commit_message>
<xml_diff>
--- a/docs/presentations/synapsegit_user_scenarios_ja.pptx
+++ b/docs/presentations/synapsegit_user_scenarios_ja.pptx
@@ -5502,13 +5502,718 @@
       </p:sp>
       <p:sp>
         <p:nvSpPr>
-          <p:cNvPr id="11" name="今すぐ試せる·v0.9.0" title="今すぐ試せる·v0.9.0" descr="今すぐ試せる·v0.9.0"/>
+          <p:cNvPr id="11" name="構想・未実装" title="構想・未実装" descr="構想・未実装"/>
           <p:cNvSpPr/>
           <p:nvPr/>
         </p:nvSpPr>
         <p:spPr>
           <a:xfrm>
             <a:off x="2578608" y="2441448"/>
+            <a:ext cx="1481328" cy="237744"/>
+          </a:xfrm>
+          <a:prstGeom prst="roundRect">
+            <a:avLst/>
+          </a:prstGeom>
+          <a:solidFill>
+            <a:srgbClr val="F5E4D4"/>
+          </a:solidFill>
+          <a:ln w="8890">
+            <a:solidFill>
+              <a:srgbClr val="8C450E"/>
+            </a:solidFill>
+          </a:ln>
+        </p:spPr>
+        <p:style>
+          <a:lnRef idx="1">
+            <a:schemeClr val="accent1"/>
+          </a:lnRef>
+          <a:fillRef idx="3">
+            <a:schemeClr val="accent1"/>
+          </a:fillRef>
+          <a:effectRef idx="2">
+            <a:schemeClr val="accent1"/>
+          </a:effectRef>
+          <a:fontRef idx="minor">
+            <a:schemeClr val="lt1"/>
+          </a:fontRef>
+        </p:style>
+        <p:txBody>
+          <a:bodyPr rtlCol="0" anchor="ctr" lIns="0" rIns="0" tIns="0" bIns="0"/>
+          <a:lstStyle/>
+          <a:p>
+            <a:pPr algn="ctr"/>
+            <a:r>
+              <a:rPr sz="1050" b="1" lang="ja-JP">
+                <a:solidFill>
+                  <a:srgbClr val="8C450E"/>
+                </a:solidFill>
+                <a:latin typeface="Noto Sans JP"/>
+                <a:ea typeface="Noto Sans JP"/>
+              </a:rPr>
+              <a:t>構想・未実装</a:t>
+            </a:r>
+          </a:p>
+        </p:txBody>
+      </p:sp>
+      <p:sp>
+        <p:nvSpPr>
+          <p:cNvPr id="12" name="Card: 02  条件を決める">
+            <a:extLst>
+              <a:ext uri="{C183D7F6-B498-43B3-948B-1728B52AA6E4}">
+                <adec:decorative xmlns:adec="http://schemas.microsoft.com/office/drawing/2017/decorative" val="1"/>
+              </a:ext>
+            </a:extLst>
+          </p:cNvPr>
+          <p:cNvSpPr/>
+          <p:nvPr/>
+        </p:nvSpPr>
+        <p:spPr>
+          <a:xfrm>
+            <a:off x="4407407" y="2560320"/>
+            <a:ext cx="3456432" cy="1024128"/>
+          </a:xfrm>
+          <a:prstGeom prst="roundRect">
+            <a:avLst/>
+          </a:prstGeom>
+          <a:solidFill>
+            <a:srgbClr val="FFFFFF"/>
+          </a:solidFill>
+          <a:ln w="10160">
+            <a:solidFill>
+              <a:srgbClr val="7B858A"/>
+            </a:solidFill>
+          </a:ln>
+        </p:spPr>
+        <p:style>
+          <a:lnRef idx="1">
+            <a:schemeClr val="accent1"/>
+          </a:lnRef>
+          <a:fillRef idx="3">
+            <a:schemeClr val="accent1"/>
+          </a:fillRef>
+          <a:effectRef idx="2">
+            <a:schemeClr val="accent1"/>
+          </a:effectRef>
+          <a:fontRef idx="minor">
+            <a:schemeClr val="lt1"/>
+          </a:fontRef>
+        </p:style>
+        <p:txBody>
+          <a:bodyPr rtlCol="0" anchor="ctr"/>
+          <a:lstStyle/>
+          <a:p>
+            <a:pPr algn="ctr"/>
+          </a:p>
+        </p:txBody>
+      </p:sp>
+      <p:sp>
+        <p:nvSpPr>
+          <p:cNvPr id="13" name="Accent: 02  条件を決める">
+            <a:extLst>
+              <a:ext uri="{C183D7F6-B498-43B3-948B-1728B52AA6E4}">
+                <adec:decorative xmlns:adec="http://schemas.microsoft.com/office/drawing/2017/decorative" val="1"/>
+              </a:ext>
+            </a:extLst>
+          </p:cNvPr>
+          <p:cNvSpPr/>
+          <p:nvPr/>
+        </p:nvSpPr>
+        <p:spPr>
+          <a:xfrm>
+            <a:off x="4571999" y="2724912"/>
+            <a:ext cx="128016" cy="694944"/>
+          </a:xfrm>
+          <a:prstGeom prst="roundRect">
+            <a:avLst/>
+          </a:prstGeom>
+          <a:solidFill>
+            <a:srgbClr val="0B6E69"/>
+          </a:solidFill>
+          <a:ln>
+            <a:noFill/>
+          </a:ln>
+        </p:spPr>
+        <p:style>
+          <a:lnRef idx="1">
+            <a:schemeClr val="accent1"/>
+          </a:lnRef>
+          <a:fillRef idx="3">
+            <a:schemeClr val="accent1"/>
+          </a:fillRef>
+          <a:effectRef idx="2">
+            <a:schemeClr val="accent1"/>
+          </a:effectRef>
+          <a:fontRef idx="minor">
+            <a:schemeClr val="lt1"/>
+          </a:fontRef>
+        </p:style>
+        <p:txBody>
+          <a:bodyPr rtlCol="0" anchor="ctr"/>
+          <a:lstStyle/>
+          <a:p>
+            <a:pPr algn="ctr"/>
+          </a:p>
+        </p:txBody>
+      </p:sp>
+      <p:sp>
+        <p:nvSpPr>
+          <p:cNvPr id="14" name="Text: 02  条件を決める"/>
+          <p:cNvSpPr txBox="1"/>
+          <p:nvPr/>
+        </p:nvSpPr>
+        <p:spPr>
+          <a:xfrm>
+            <a:off x="4846319" y="2688336"/>
+            <a:ext cx="2834639" cy="347472"/>
+          </a:xfrm>
+          <a:prstGeom prst="rect">
+            <a:avLst/>
+          </a:prstGeom>
+          <a:noFill/>
+        </p:spPr>
+        <p:txBody>
+          <a:bodyPr wrap="square" lIns="18288" rIns="18288" tIns="18288" bIns="18288" anchor="t">
+            <a:spAutoFit/>
+          </a:bodyPr>
+          <a:lstStyle/>
+          <a:p>
+            <a:pPr algn="l">
+              <a:spcAft>
+                <a:spcPts val="0"/>
+              </a:spcAft>
+            </a:pPr>
+            <a:r>
+              <a:rPr sz="1550" b="1" lang="ja-JP">
+                <a:solidFill>
+                  <a:srgbClr val="0B6E69"/>
+                </a:solidFill>
+                <a:latin typeface="Noto Sans JP"/>
+                <a:ea typeface="Noto Sans JP"/>
+              </a:rPr>
+              <a:t>02  条件を決める</a:t>
+            </a:r>
+          </a:p>
+        </p:txBody>
+      </p:sp>
+      <p:sp>
+        <p:nvSpPr>
+          <p:cNvPr id="15" name="Text: Imported／Repeatable／Cali"/>
+          <p:cNvSpPr txBox="1"/>
+          <p:nvPr/>
+        </p:nvSpPr>
+        <p:spPr>
+          <a:xfrm>
+            <a:off x="4846319" y="3090672"/>
+            <a:ext cx="2834639" cy="384048"/>
+          </a:xfrm>
+          <a:prstGeom prst="rect">
+            <a:avLst/>
+          </a:prstGeom>
+          <a:noFill/>
+        </p:spPr>
+        <p:txBody>
+          <a:bodyPr wrap="square" lIns="18288" rIns="18288" tIns="18288" bIns="18288" anchor="t">
+            <a:spAutoFit/>
+          </a:bodyPr>
+          <a:lstStyle/>
+          <a:p>
+            <a:pPr algn="l">
+              <a:spcAft>
+                <a:spcPts val="0"/>
+              </a:spcAft>
+            </a:pPr>
+            <a:r>
+              <a:rPr sz="1400" b="0" lang="ja-JP">
+                <a:solidFill>
+                  <a:srgbClr val="13202B"/>
+                </a:solidFill>
+                <a:latin typeface="Noto Sans JP"/>
+                <a:ea typeface="Noto Sans JP"/>
+              </a:rPr>
+              <a:t>Imported／Repeatable／Calibrated</a:t>
+            </a:r>
+          </a:p>
+        </p:txBody>
+      </p:sp>
+      <p:sp>
+        <p:nvSpPr>
+          <p:cNvPr id="16" name="構想・未実装" title="構想・未実装" descr="構想・未実装"/>
+          <p:cNvSpPr/>
+          <p:nvPr/>
+        </p:nvSpPr>
+        <p:spPr>
+          <a:xfrm>
+            <a:off x="6327648" y="2441448"/>
+            <a:ext cx="1481328" cy="237744"/>
+          </a:xfrm>
+          <a:prstGeom prst="roundRect">
+            <a:avLst/>
+          </a:prstGeom>
+          <a:solidFill>
+            <a:srgbClr val="F5E4D4"/>
+          </a:solidFill>
+          <a:ln w="8890">
+            <a:solidFill>
+              <a:srgbClr val="8C450E"/>
+            </a:solidFill>
+          </a:ln>
+        </p:spPr>
+        <p:style>
+          <a:lnRef idx="1">
+            <a:schemeClr val="accent1"/>
+          </a:lnRef>
+          <a:fillRef idx="3">
+            <a:schemeClr val="accent1"/>
+          </a:fillRef>
+          <a:effectRef idx="2">
+            <a:schemeClr val="accent1"/>
+          </a:effectRef>
+          <a:fontRef idx="minor">
+            <a:schemeClr val="lt1"/>
+          </a:fontRef>
+        </p:style>
+        <p:txBody>
+          <a:bodyPr rtlCol="0" anchor="ctr" lIns="0" rIns="0" tIns="0" bIns="0"/>
+          <a:lstStyle/>
+          <a:p>
+            <a:pPr algn="ctr"/>
+            <a:r>
+              <a:rPr sz="1050" b="1" lang="ja-JP">
+                <a:solidFill>
+                  <a:srgbClr val="8C450E"/>
+                </a:solidFill>
+                <a:latin typeface="Noto Sans JP"/>
+                <a:ea typeface="Noto Sans JP"/>
+              </a:rPr>
+              <a:t>構想・未実装</a:t>
+            </a:r>
+          </a:p>
+        </p:txBody>
+      </p:sp>
+      <p:sp>
+        <p:nvSpPr>
+          <p:cNvPr id="17" name="Card: 03  節目で撮る">
+            <a:extLst>
+              <a:ext uri="{C183D7F6-B498-43B3-948B-1728B52AA6E4}">
+                <adec:decorative xmlns:adec="http://schemas.microsoft.com/office/drawing/2017/decorative" val="1"/>
+              </a:ext>
+            </a:extLst>
+          </p:cNvPr>
+          <p:cNvSpPr/>
+          <p:nvPr/>
+        </p:nvSpPr>
+        <p:spPr>
+          <a:xfrm>
+            <a:off x="8156448" y="2560320"/>
+            <a:ext cx="3456432" cy="1024128"/>
+          </a:xfrm>
+          <a:prstGeom prst="roundRect">
+            <a:avLst/>
+          </a:prstGeom>
+          <a:solidFill>
+            <a:srgbClr val="FFFFFF"/>
+          </a:solidFill>
+          <a:ln w="10160">
+            <a:solidFill>
+              <a:srgbClr val="7B858A"/>
+            </a:solidFill>
+          </a:ln>
+        </p:spPr>
+        <p:style>
+          <a:lnRef idx="1">
+            <a:schemeClr val="accent1"/>
+          </a:lnRef>
+          <a:fillRef idx="3">
+            <a:schemeClr val="accent1"/>
+          </a:fillRef>
+          <a:effectRef idx="2">
+            <a:schemeClr val="accent1"/>
+          </a:effectRef>
+          <a:fontRef idx="minor">
+            <a:schemeClr val="lt1"/>
+          </a:fontRef>
+        </p:style>
+        <p:txBody>
+          <a:bodyPr rtlCol="0" anchor="ctr"/>
+          <a:lstStyle/>
+          <a:p>
+            <a:pPr algn="ctr"/>
+          </a:p>
+        </p:txBody>
+      </p:sp>
+      <p:sp>
+        <p:nvSpPr>
+          <p:cNvPr id="18" name="Accent: 03  節目で撮る">
+            <a:extLst>
+              <a:ext uri="{C183D7F6-B498-43B3-948B-1728B52AA6E4}">
+                <adec:decorative xmlns:adec="http://schemas.microsoft.com/office/drawing/2017/decorative" val="1"/>
+              </a:ext>
+            </a:extLst>
+          </p:cNvPr>
+          <p:cNvSpPr/>
+          <p:nvPr/>
+        </p:nvSpPr>
+        <p:spPr>
+          <a:xfrm>
+            <a:off x="8321040" y="2724912"/>
+            <a:ext cx="128016" cy="694944"/>
+          </a:xfrm>
+          <a:prstGeom prst="roundRect">
+            <a:avLst/>
+          </a:prstGeom>
+          <a:solidFill>
+            <a:srgbClr val="8C450E"/>
+          </a:solidFill>
+          <a:ln>
+            <a:noFill/>
+          </a:ln>
+        </p:spPr>
+        <p:style>
+          <a:lnRef idx="1">
+            <a:schemeClr val="accent1"/>
+          </a:lnRef>
+          <a:fillRef idx="3">
+            <a:schemeClr val="accent1"/>
+          </a:fillRef>
+          <a:effectRef idx="2">
+            <a:schemeClr val="accent1"/>
+          </a:effectRef>
+          <a:fontRef idx="minor">
+            <a:schemeClr val="lt1"/>
+          </a:fontRef>
+        </p:style>
+        <p:txBody>
+          <a:bodyPr rtlCol="0" anchor="ctr"/>
+          <a:lstStyle/>
+          <a:p>
+            <a:pPr algn="ctr"/>
+          </a:p>
+        </p:txBody>
+      </p:sp>
+      <p:sp>
+        <p:nvSpPr>
+          <p:cNvPr id="19" name="Text: 03  節目で撮る"/>
+          <p:cNvSpPr txBox="1"/>
+          <p:nvPr/>
+        </p:nvSpPr>
+        <p:spPr>
+          <a:xfrm>
+            <a:off x="8595360" y="2688336"/>
+            <a:ext cx="2834639" cy="347472"/>
+          </a:xfrm>
+          <a:prstGeom prst="rect">
+            <a:avLst/>
+          </a:prstGeom>
+          <a:noFill/>
+        </p:spPr>
+        <p:txBody>
+          <a:bodyPr wrap="square" lIns="18288" rIns="18288" tIns="18288" bIns="18288" anchor="t">
+            <a:spAutoFit/>
+          </a:bodyPr>
+          <a:lstStyle/>
+          <a:p>
+            <a:pPr algn="l">
+              <a:spcAft>
+                <a:spcPts val="0"/>
+              </a:spcAft>
+            </a:pPr>
+            <a:r>
+              <a:rPr sz="1550" b="1" lang="ja-JP">
+                <a:solidFill>
+                  <a:srgbClr val="8C450E"/>
+                </a:solidFill>
+                <a:latin typeface="Noto Sans JP"/>
+                <a:ea typeface="Noto Sans JP"/>
+              </a:rPr>
+              <a:t>03  節目で撮る</a:t>
+            </a:r>
+          </a:p>
+        </p:txBody>
+      </p:sp>
+      <p:sp>
+        <p:nvSpPr>
+          <p:cNvPr id="20" name="Text: 作業終了／承認／Hold Point"/>
+          <p:cNvSpPr txBox="1"/>
+          <p:nvPr/>
+        </p:nvSpPr>
+        <p:spPr>
+          <a:xfrm>
+            <a:off x="8595360" y="3090672"/>
+            <a:ext cx="2834639" cy="384048"/>
+          </a:xfrm>
+          <a:prstGeom prst="rect">
+            <a:avLst/>
+          </a:prstGeom>
+          <a:noFill/>
+        </p:spPr>
+        <p:txBody>
+          <a:bodyPr wrap="square" lIns="18288" rIns="18288" tIns="18288" bIns="18288" anchor="t">
+            <a:spAutoFit/>
+          </a:bodyPr>
+          <a:lstStyle/>
+          <a:p>
+            <a:pPr algn="l">
+              <a:spcAft>
+                <a:spcPts val="0"/>
+              </a:spcAft>
+            </a:pPr>
+            <a:r>
+              <a:rPr sz="1400" b="0" lang="ja-JP">
+                <a:solidFill>
+                  <a:srgbClr val="13202B"/>
+                </a:solidFill>
+                <a:latin typeface="Noto Sans JP"/>
+                <a:ea typeface="Noto Sans JP"/>
+              </a:rPr>
+              <a:t>作業終了／承認／Hold Point</a:t>
+            </a:r>
+          </a:p>
+        </p:txBody>
+      </p:sp>
+      <p:sp>
+        <p:nvSpPr>
+          <p:cNvPr id="21" name="構想・未実装" title="構想・未実装" descr="構想・未実装"/>
+          <p:cNvSpPr/>
+          <p:nvPr/>
+        </p:nvSpPr>
+        <p:spPr>
+          <a:xfrm>
+            <a:off x="10076688" y="2441448"/>
+            <a:ext cx="1481328" cy="237744"/>
+          </a:xfrm>
+          <a:prstGeom prst="roundRect">
+            <a:avLst/>
+          </a:prstGeom>
+          <a:solidFill>
+            <a:srgbClr val="F5E4D4"/>
+          </a:solidFill>
+          <a:ln w="8890">
+            <a:solidFill>
+              <a:srgbClr val="8C450E"/>
+            </a:solidFill>
+          </a:ln>
+        </p:spPr>
+        <p:style>
+          <a:lnRef idx="1">
+            <a:schemeClr val="accent1"/>
+          </a:lnRef>
+          <a:fillRef idx="3">
+            <a:schemeClr val="accent1"/>
+          </a:fillRef>
+          <a:effectRef idx="2">
+            <a:schemeClr val="accent1"/>
+          </a:effectRef>
+          <a:fontRef idx="minor">
+            <a:schemeClr val="lt1"/>
+          </a:fontRef>
+        </p:style>
+        <p:txBody>
+          <a:bodyPr rtlCol="0" anchor="ctr" lIns="0" rIns="0" tIns="0" bIns="0"/>
+          <a:lstStyle/>
+          <a:p>
+            <a:pPr algn="ctr"/>
+            <a:r>
+              <a:rPr sz="1050" b="1" lang="ja-JP">
+                <a:solidFill>
+                  <a:srgbClr val="8C450E"/>
+                </a:solidFill>
+                <a:latin typeface="Noto Sans JP"/>
+                <a:ea typeface="Noto Sans JP"/>
+              </a:rPr>
+              <a:t>構想・未実装</a:t>
+            </a:r>
+          </a:p>
+        </p:txBody>
+      </p:sp>
+      <p:sp>
+        <p:nvSpPr>
+          <p:cNvPr id="22" name="Card: 04  3画像を比較">
+            <a:extLst>
+              <a:ext uri="{C183D7F6-B498-43B3-948B-1728B52AA6E4}">
+                <adec:decorative xmlns:adec="http://schemas.microsoft.com/office/drawing/2017/decorative" val="1"/>
+              </a:ext>
+            </a:extLst>
+          </p:cNvPr>
+          <p:cNvSpPr/>
+          <p:nvPr/>
+        </p:nvSpPr>
+        <p:spPr>
+          <a:xfrm>
+            <a:off x="658368" y="3840479"/>
+            <a:ext cx="3456432" cy="1024128"/>
+          </a:xfrm>
+          <a:prstGeom prst="roundRect">
+            <a:avLst/>
+          </a:prstGeom>
+          <a:solidFill>
+            <a:srgbClr val="FFFFFF"/>
+          </a:solidFill>
+          <a:ln w="10160">
+            <a:solidFill>
+              <a:srgbClr val="7B858A"/>
+            </a:solidFill>
+          </a:ln>
+        </p:spPr>
+        <p:style>
+          <a:lnRef idx="1">
+            <a:schemeClr val="accent1"/>
+          </a:lnRef>
+          <a:fillRef idx="3">
+            <a:schemeClr val="accent1"/>
+          </a:fillRef>
+          <a:effectRef idx="2">
+            <a:schemeClr val="accent1"/>
+          </a:effectRef>
+          <a:fontRef idx="minor">
+            <a:schemeClr val="lt1"/>
+          </a:fontRef>
+        </p:style>
+        <p:txBody>
+          <a:bodyPr rtlCol="0" anchor="ctr"/>
+          <a:lstStyle/>
+          <a:p>
+            <a:pPr algn="ctr"/>
+          </a:p>
+        </p:txBody>
+      </p:sp>
+      <p:sp>
+        <p:nvSpPr>
+          <p:cNvPr id="23" name="Accent: 04  3画像を比較">
+            <a:extLst>
+              <a:ext uri="{C183D7F6-B498-43B3-948B-1728B52AA6E4}">
+                <adec:decorative xmlns:adec="http://schemas.microsoft.com/office/drawing/2017/decorative" val="1"/>
+              </a:ext>
+            </a:extLst>
+          </p:cNvPr>
+          <p:cNvSpPr/>
+          <p:nvPr/>
+        </p:nvSpPr>
+        <p:spPr>
+          <a:xfrm>
+            <a:off x="822959" y="4005071"/>
+            <a:ext cx="128016" cy="694944"/>
+          </a:xfrm>
+          <a:prstGeom prst="roundRect">
+            <a:avLst/>
+          </a:prstGeom>
+          <a:solidFill>
+            <a:srgbClr val="5E6873"/>
+          </a:solidFill>
+          <a:ln>
+            <a:noFill/>
+          </a:ln>
+        </p:spPr>
+        <p:style>
+          <a:lnRef idx="1">
+            <a:schemeClr val="accent1"/>
+          </a:lnRef>
+          <a:fillRef idx="3">
+            <a:schemeClr val="accent1"/>
+          </a:fillRef>
+          <a:effectRef idx="2">
+            <a:schemeClr val="accent1"/>
+          </a:effectRef>
+          <a:fontRef idx="minor">
+            <a:schemeClr val="lt1"/>
+          </a:fontRef>
+        </p:style>
+        <p:txBody>
+          <a:bodyPr rtlCol="0" anchor="ctr"/>
+          <a:lstStyle/>
+          <a:p>
+            <a:pPr algn="ctr"/>
+          </a:p>
+        </p:txBody>
+      </p:sp>
+      <p:sp>
+        <p:nvSpPr>
+          <p:cNvPr id="24" name="Text: 04  3画像を比較"/>
+          <p:cNvSpPr txBox="1"/>
+          <p:nvPr/>
+        </p:nvSpPr>
+        <p:spPr>
+          <a:xfrm>
+            <a:off x="1097280" y="3968495"/>
+            <a:ext cx="2834639" cy="347472"/>
+          </a:xfrm>
+          <a:prstGeom prst="rect">
+            <a:avLst/>
+          </a:prstGeom>
+          <a:noFill/>
+        </p:spPr>
+        <p:txBody>
+          <a:bodyPr wrap="square" lIns="18288" rIns="18288" tIns="18288" bIns="18288" anchor="t">
+            <a:spAutoFit/>
+          </a:bodyPr>
+          <a:lstStyle/>
+          <a:p>
+            <a:pPr algn="l">
+              <a:spcAft>
+                <a:spcPts val="0"/>
+              </a:spcAft>
+            </a:pPr>
+            <a:r>
+              <a:rPr sz="1550" b="1" lang="ja-JP">
+                <a:solidFill>
+                  <a:srgbClr val="5E6873"/>
+                </a:solidFill>
+                <a:latin typeface="Noto Sans JP"/>
+                <a:ea typeface="Noto Sans JP"/>
+              </a:rPr>
+              <a:t>04  3画像を比較</a:t>
+            </a:r>
+          </a:p>
+        </p:txBody>
+      </p:sp>
+      <p:sp>
+        <p:nvSpPr>
+          <p:cNvPr id="25" name="Text: Original／Current／外部候補"/>
+          <p:cNvSpPr txBox="1"/>
+          <p:nvPr/>
+        </p:nvSpPr>
+        <p:spPr>
+          <a:xfrm>
+            <a:off x="1097280" y="4370831"/>
+            <a:ext cx="2834639" cy="384048"/>
+          </a:xfrm>
+          <a:prstGeom prst="rect">
+            <a:avLst/>
+          </a:prstGeom>
+          <a:noFill/>
+        </p:spPr>
+        <p:txBody>
+          <a:bodyPr wrap="square" lIns="18288" rIns="18288" tIns="18288" bIns="18288" anchor="t">
+            <a:spAutoFit/>
+          </a:bodyPr>
+          <a:lstStyle/>
+          <a:p>
+            <a:pPr algn="l">
+              <a:spcAft>
+                <a:spcPts val="0"/>
+              </a:spcAft>
+            </a:pPr>
+            <a:r>
+              <a:rPr sz="1400" b="0" lang="ja-JP">
+                <a:solidFill>
+                  <a:srgbClr val="13202B"/>
+                </a:solidFill>
+                <a:latin typeface="Noto Sans JP"/>
+                <a:ea typeface="Noto Sans JP"/>
+              </a:rPr>
+              <a:t>Original／Current／外部候補</a:t>
+            </a:r>
+          </a:p>
+        </p:txBody>
+      </p:sp>
+      <p:sp>
+        <p:nvSpPr>
+          <p:cNvPr id="26" name="今すぐ試せる·v0.9.0" title="今すぐ試せる·v0.9.0" descr="今すぐ試せる·v0.9.0"/>
+          <p:cNvSpPr/>
+          <p:nvPr/>
+        </p:nvSpPr>
+        <p:spPr>
+          <a:xfrm>
+            <a:off x="2578608" y="3721607"/>
             <a:ext cx="1481328" cy="237744"/>
           </a:xfrm>
           <a:prstGeom prst="roundRect">
@@ -5557,7 +6262,7 @@
       </p:sp>
       <p:sp>
         <p:nvSpPr>
-          <p:cNvPr id="12" name="Card: 02  条件を決める">
+          <p:cNvPr id="27" name="Card: 05  人が判断">
             <a:extLst>
               <a:ext uri="{C183D7F6-B498-43B3-948B-1728B52AA6E4}">
                 <adec:decorative xmlns:adec="http://schemas.microsoft.com/office/drawing/2017/decorative" val="1"/>
@@ -5569,7 +6274,7 @@
         </p:nvSpPr>
         <p:spPr>
           <a:xfrm>
-            <a:off x="4407407" y="2560320"/>
+            <a:off x="4407407" y="3840479"/>
             <a:ext cx="3456432" cy="1024128"/>
           </a:xfrm>
           <a:prstGeom prst="roundRect">
@@ -5608,711 +6313,6 @@
       </p:sp>
       <p:sp>
         <p:nvSpPr>
-          <p:cNvPr id="13" name="Accent: 02  条件を決める">
-            <a:extLst>
-              <a:ext uri="{C183D7F6-B498-43B3-948B-1728B52AA6E4}">
-                <adec:decorative xmlns:adec="http://schemas.microsoft.com/office/drawing/2017/decorative" val="1"/>
-              </a:ext>
-            </a:extLst>
-          </p:cNvPr>
-          <p:cNvSpPr/>
-          <p:nvPr/>
-        </p:nvSpPr>
-        <p:spPr>
-          <a:xfrm>
-            <a:off x="4571999" y="2724912"/>
-            <a:ext cx="128016" cy="694944"/>
-          </a:xfrm>
-          <a:prstGeom prst="roundRect">
-            <a:avLst/>
-          </a:prstGeom>
-          <a:solidFill>
-            <a:srgbClr val="0B6E69"/>
-          </a:solidFill>
-          <a:ln>
-            <a:noFill/>
-          </a:ln>
-        </p:spPr>
-        <p:style>
-          <a:lnRef idx="1">
-            <a:schemeClr val="accent1"/>
-          </a:lnRef>
-          <a:fillRef idx="3">
-            <a:schemeClr val="accent1"/>
-          </a:fillRef>
-          <a:effectRef idx="2">
-            <a:schemeClr val="accent1"/>
-          </a:effectRef>
-          <a:fontRef idx="minor">
-            <a:schemeClr val="lt1"/>
-          </a:fontRef>
-        </p:style>
-        <p:txBody>
-          <a:bodyPr rtlCol="0" anchor="ctr"/>
-          <a:lstStyle/>
-          <a:p>
-            <a:pPr algn="ctr"/>
-          </a:p>
-        </p:txBody>
-      </p:sp>
-      <p:sp>
-        <p:nvSpPr>
-          <p:cNvPr id="14" name="Text: 02  条件を決める"/>
-          <p:cNvSpPr txBox="1"/>
-          <p:nvPr/>
-        </p:nvSpPr>
-        <p:spPr>
-          <a:xfrm>
-            <a:off x="4846319" y="2688336"/>
-            <a:ext cx="2834639" cy="347472"/>
-          </a:xfrm>
-          <a:prstGeom prst="rect">
-            <a:avLst/>
-          </a:prstGeom>
-          <a:noFill/>
-        </p:spPr>
-        <p:txBody>
-          <a:bodyPr wrap="square" lIns="18288" rIns="18288" tIns="18288" bIns="18288" anchor="t">
-            <a:spAutoFit/>
-          </a:bodyPr>
-          <a:lstStyle/>
-          <a:p>
-            <a:pPr algn="l">
-              <a:spcAft>
-                <a:spcPts val="0"/>
-              </a:spcAft>
-            </a:pPr>
-            <a:r>
-              <a:rPr sz="1550" b="1" lang="ja-JP">
-                <a:solidFill>
-                  <a:srgbClr val="0B6E69"/>
-                </a:solidFill>
-                <a:latin typeface="Noto Sans JP"/>
-                <a:ea typeface="Noto Sans JP"/>
-              </a:rPr>
-              <a:t>02  条件を決める</a:t>
-            </a:r>
-          </a:p>
-        </p:txBody>
-      </p:sp>
-      <p:sp>
-        <p:nvSpPr>
-          <p:cNvPr id="15" name="Text: Imported／Repeatable／Cali"/>
-          <p:cNvSpPr txBox="1"/>
-          <p:nvPr/>
-        </p:nvSpPr>
-        <p:spPr>
-          <a:xfrm>
-            <a:off x="4846319" y="3090672"/>
-            <a:ext cx="2834639" cy="384048"/>
-          </a:xfrm>
-          <a:prstGeom prst="rect">
-            <a:avLst/>
-          </a:prstGeom>
-          <a:noFill/>
-        </p:spPr>
-        <p:txBody>
-          <a:bodyPr wrap="square" lIns="18288" rIns="18288" tIns="18288" bIns="18288" anchor="t">
-            <a:spAutoFit/>
-          </a:bodyPr>
-          <a:lstStyle/>
-          <a:p>
-            <a:pPr algn="l">
-              <a:spcAft>
-                <a:spcPts val="0"/>
-              </a:spcAft>
-            </a:pPr>
-            <a:r>
-              <a:rPr sz="1400" b="0" lang="ja-JP">
-                <a:solidFill>
-                  <a:srgbClr val="13202B"/>
-                </a:solidFill>
-                <a:latin typeface="Noto Sans JP"/>
-                <a:ea typeface="Noto Sans JP"/>
-              </a:rPr>
-              <a:t>Imported／Repeatable／Calibrated</a:t>
-            </a:r>
-          </a:p>
-        </p:txBody>
-      </p:sp>
-      <p:sp>
-        <p:nvSpPr>
-          <p:cNvPr id="16" name="構想・未実装" title="構想・未実装" descr="構想・未実装"/>
-          <p:cNvSpPr/>
-          <p:nvPr/>
-        </p:nvSpPr>
-        <p:spPr>
-          <a:xfrm>
-            <a:off x="6327648" y="2441448"/>
-            <a:ext cx="1481328" cy="237744"/>
-          </a:xfrm>
-          <a:prstGeom prst="roundRect">
-            <a:avLst/>
-          </a:prstGeom>
-          <a:solidFill>
-            <a:srgbClr val="F5E4D4"/>
-          </a:solidFill>
-          <a:ln w="8890">
-            <a:solidFill>
-              <a:srgbClr val="8C450E"/>
-            </a:solidFill>
-          </a:ln>
-        </p:spPr>
-        <p:style>
-          <a:lnRef idx="1">
-            <a:schemeClr val="accent1"/>
-          </a:lnRef>
-          <a:fillRef idx="3">
-            <a:schemeClr val="accent1"/>
-          </a:fillRef>
-          <a:effectRef idx="2">
-            <a:schemeClr val="accent1"/>
-          </a:effectRef>
-          <a:fontRef idx="minor">
-            <a:schemeClr val="lt1"/>
-          </a:fontRef>
-        </p:style>
-        <p:txBody>
-          <a:bodyPr rtlCol="0" anchor="ctr" lIns="0" rIns="0" tIns="0" bIns="0"/>
-          <a:lstStyle/>
-          <a:p>
-            <a:pPr algn="ctr"/>
-            <a:r>
-              <a:rPr sz="1050" b="1" lang="ja-JP">
-                <a:solidFill>
-                  <a:srgbClr val="8C450E"/>
-                </a:solidFill>
-                <a:latin typeface="Noto Sans JP"/>
-                <a:ea typeface="Noto Sans JP"/>
-              </a:rPr>
-              <a:t>構想・未実装</a:t>
-            </a:r>
-          </a:p>
-        </p:txBody>
-      </p:sp>
-      <p:sp>
-        <p:nvSpPr>
-          <p:cNvPr id="17" name="Card: 03  節目で撮る">
-            <a:extLst>
-              <a:ext uri="{C183D7F6-B498-43B3-948B-1728B52AA6E4}">
-                <adec:decorative xmlns:adec="http://schemas.microsoft.com/office/drawing/2017/decorative" val="1"/>
-              </a:ext>
-            </a:extLst>
-          </p:cNvPr>
-          <p:cNvSpPr/>
-          <p:nvPr/>
-        </p:nvSpPr>
-        <p:spPr>
-          <a:xfrm>
-            <a:off x="8156448" y="2560320"/>
-            <a:ext cx="3456432" cy="1024128"/>
-          </a:xfrm>
-          <a:prstGeom prst="roundRect">
-            <a:avLst/>
-          </a:prstGeom>
-          <a:solidFill>
-            <a:srgbClr val="FFFFFF"/>
-          </a:solidFill>
-          <a:ln w="10160">
-            <a:solidFill>
-              <a:srgbClr val="7B858A"/>
-            </a:solidFill>
-          </a:ln>
-        </p:spPr>
-        <p:style>
-          <a:lnRef idx="1">
-            <a:schemeClr val="accent1"/>
-          </a:lnRef>
-          <a:fillRef idx="3">
-            <a:schemeClr val="accent1"/>
-          </a:fillRef>
-          <a:effectRef idx="2">
-            <a:schemeClr val="accent1"/>
-          </a:effectRef>
-          <a:fontRef idx="minor">
-            <a:schemeClr val="lt1"/>
-          </a:fontRef>
-        </p:style>
-        <p:txBody>
-          <a:bodyPr rtlCol="0" anchor="ctr"/>
-          <a:lstStyle/>
-          <a:p>
-            <a:pPr algn="ctr"/>
-          </a:p>
-        </p:txBody>
-      </p:sp>
-      <p:sp>
-        <p:nvSpPr>
-          <p:cNvPr id="18" name="Accent: 03  節目で撮る">
-            <a:extLst>
-              <a:ext uri="{C183D7F6-B498-43B3-948B-1728B52AA6E4}">
-                <adec:decorative xmlns:adec="http://schemas.microsoft.com/office/drawing/2017/decorative" val="1"/>
-              </a:ext>
-            </a:extLst>
-          </p:cNvPr>
-          <p:cNvSpPr/>
-          <p:nvPr/>
-        </p:nvSpPr>
-        <p:spPr>
-          <a:xfrm>
-            <a:off x="8321040" y="2724912"/>
-            <a:ext cx="128016" cy="694944"/>
-          </a:xfrm>
-          <a:prstGeom prst="roundRect">
-            <a:avLst/>
-          </a:prstGeom>
-          <a:solidFill>
-            <a:srgbClr val="8C450E"/>
-          </a:solidFill>
-          <a:ln>
-            <a:noFill/>
-          </a:ln>
-        </p:spPr>
-        <p:style>
-          <a:lnRef idx="1">
-            <a:schemeClr val="accent1"/>
-          </a:lnRef>
-          <a:fillRef idx="3">
-            <a:schemeClr val="accent1"/>
-          </a:fillRef>
-          <a:effectRef idx="2">
-            <a:schemeClr val="accent1"/>
-          </a:effectRef>
-          <a:fontRef idx="minor">
-            <a:schemeClr val="lt1"/>
-          </a:fontRef>
-        </p:style>
-        <p:txBody>
-          <a:bodyPr rtlCol="0" anchor="ctr"/>
-          <a:lstStyle/>
-          <a:p>
-            <a:pPr algn="ctr"/>
-          </a:p>
-        </p:txBody>
-      </p:sp>
-      <p:sp>
-        <p:nvSpPr>
-          <p:cNvPr id="19" name="Text: 03  節目で撮る"/>
-          <p:cNvSpPr txBox="1"/>
-          <p:nvPr/>
-        </p:nvSpPr>
-        <p:spPr>
-          <a:xfrm>
-            <a:off x="8595360" y="2688336"/>
-            <a:ext cx="2834639" cy="347472"/>
-          </a:xfrm>
-          <a:prstGeom prst="rect">
-            <a:avLst/>
-          </a:prstGeom>
-          <a:noFill/>
-        </p:spPr>
-        <p:txBody>
-          <a:bodyPr wrap="square" lIns="18288" rIns="18288" tIns="18288" bIns="18288" anchor="t">
-            <a:spAutoFit/>
-          </a:bodyPr>
-          <a:lstStyle/>
-          <a:p>
-            <a:pPr algn="l">
-              <a:spcAft>
-                <a:spcPts val="0"/>
-              </a:spcAft>
-            </a:pPr>
-            <a:r>
-              <a:rPr sz="1550" b="1" lang="ja-JP">
-                <a:solidFill>
-                  <a:srgbClr val="8C450E"/>
-                </a:solidFill>
-                <a:latin typeface="Noto Sans JP"/>
-                <a:ea typeface="Noto Sans JP"/>
-              </a:rPr>
-              <a:t>03  節目で撮る</a:t>
-            </a:r>
-          </a:p>
-        </p:txBody>
-      </p:sp>
-      <p:sp>
-        <p:nvSpPr>
-          <p:cNvPr id="20" name="Text: 作業終了／承認／Hold Point"/>
-          <p:cNvSpPr txBox="1"/>
-          <p:nvPr/>
-        </p:nvSpPr>
-        <p:spPr>
-          <a:xfrm>
-            <a:off x="8595360" y="3090672"/>
-            <a:ext cx="2834639" cy="384048"/>
-          </a:xfrm>
-          <a:prstGeom prst="rect">
-            <a:avLst/>
-          </a:prstGeom>
-          <a:noFill/>
-        </p:spPr>
-        <p:txBody>
-          <a:bodyPr wrap="square" lIns="18288" rIns="18288" tIns="18288" bIns="18288" anchor="t">
-            <a:spAutoFit/>
-          </a:bodyPr>
-          <a:lstStyle/>
-          <a:p>
-            <a:pPr algn="l">
-              <a:spcAft>
-                <a:spcPts val="0"/>
-              </a:spcAft>
-            </a:pPr>
-            <a:r>
-              <a:rPr sz="1400" b="0" lang="ja-JP">
-                <a:solidFill>
-                  <a:srgbClr val="13202B"/>
-                </a:solidFill>
-                <a:latin typeface="Noto Sans JP"/>
-                <a:ea typeface="Noto Sans JP"/>
-              </a:rPr>
-              <a:t>作業終了／承認／Hold Point</a:t>
-            </a:r>
-          </a:p>
-        </p:txBody>
-      </p:sp>
-      <p:sp>
-        <p:nvSpPr>
-          <p:cNvPr id="21" name="構想・未実装" title="構想・未実装" descr="構想・未実装"/>
-          <p:cNvSpPr/>
-          <p:nvPr/>
-        </p:nvSpPr>
-        <p:spPr>
-          <a:xfrm>
-            <a:off x="10076688" y="2441448"/>
-            <a:ext cx="1481328" cy="237744"/>
-          </a:xfrm>
-          <a:prstGeom prst="roundRect">
-            <a:avLst/>
-          </a:prstGeom>
-          <a:solidFill>
-            <a:srgbClr val="F5E4D4"/>
-          </a:solidFill>
-          <a:ln w="8890">
-            <a:solidFill>
-              <a:srgbClr val="8C450E"/>
-            </a:solidFill>
-          </a:ln>
-        </p:spPr>
-        <p:style>
-          <a:lnRef idx="1">
-            <a:schemeClr val="accent1"/>
-          </a:lnRef>
-          <a:fillRef idx="3">
-            <a:schemeClr val="accent1"/>
-          </a:fillRef>
-          <a:effectRef idx="2">
-            <a:schemeClr val="accent1"/>
-          </a:effectRef>
-          <a:fontRef idx="minor">
-            <a:schemeClr val="lt1"/>
-          </a:fontRef>
-        </p:style>
-        <p:txBody>
-          <a:bodyPr rtlCol="0" anchor="ctr" lIns="0" rIns="0" tIns="0" bIns="0"/>
-          <a:lstStyle/>
-          <a:p>
-            <a:pPr algn="ctr"/>
-            <a:r>
-              <a:rPr sz="1050" b="1" lang="ja-JP">
-                <a:solidFill>
-                  <a:srgbClr val="8C450E"/>
-                </a:solidFill>
-                <a:latin typeface="Noto Sans JP"/>
-                <a:ea typeface="Noto Sans JP"/>
-              </a:rPr>
-              <a:t>構想・未実装</a:t>
-            </a:r>
-          </a:p>
-        </p:txBody>
-      </p:sp>
-      <p:sp>
-        <p:nvSpPr>
-          <p:cNvPr id="22" name="Card: 04  三者比較">
-            <a:extLst>
-              <a:ext uri="{C183D7F6-B498-43B3-948B-1728B52AA6E4}">
-                <adec:decorative xmlns:adec="http://schemas.microsoft.com/office/drawing/2017/decorative" val="1"/>
-              </a:ext>
-            </a:extLst>
-          </p:cNvPr>
-          <p:cNvSpPr/>
-          <p:nvPr/>
-        </p:nvSpPr>
-        <p:spPr>
-          <a:xfrm>
-            <a:off x="658368" y="3840479"/>
-            <a:ext cx="3456432" cy="1024128"/>
-          </a:xfrm>
-          <a:prstGeom prst="roundRect">
-            <a:avLst/>
-          </a:prstGeom>
-          <a:solidFill>
-            <a:srgbClr val="FFFFFF"/>
-          </a:solidFill>
-          <a:ln w="10160">
-            <a:solidFill>
-              <a:srgbClr val="7B858A"/>
-            </a:solidFill>
-          </a:ln>
-        </p:spPr>
-        <p:style>
-          <a:lnRef idx="1">
-            <a:schemeClr val="accent1"/>
-          </a:lnRef>
-          <a:fillRef idx="3">
-            <a:schemeClr val="accent1"/>
-          </a:fillRef>
-          <a:effectRef idx="2">
-            <a:schemeClr val="accent1"/>
-          </a:effectRef>
-          <a:fontRef idx="minor">
-            <a:schemeClr val="lt1"/>
-          </a:fontRef>
-        </p:style>
-        <p:txBody>
-          <a:bodyPr rtlCol="0" anchor="ctr"/>
-          <a:lstStyle/>
-          <a:p>
-            <a:pPr algn="ctr"/>
-          </a:p>
-        </p:txBody>
-      </p:sp>
-      <p:sp>
-        <p:nvSpPr>
-          <p:cNvPr id="23" name="Accent: 04  三者比較">
-            <a:extLst>
-              <a:ext uri="{C183D7F6-B498-43B3-948B-1728B52AA6E4}">
-                <adec:decorative xmlns:adec="http://schemas.microsoft.com/office/drawing/2017/decorative" val="1"/>
-              </a:ext>
-            </a:extLst>
-          </p:cNvPr>
-          <p:cNvSpPr/>
-          <p:nvPr/>
-        </p:nvSpPr>
-        <p:spPr>
-          <a:xfrm>
-            <a:off x="822959" y="4005071"/>
-            <a:ext cx="128016" cy="694944"/>
-          </a:xfrm>
-          <a:prstGeom prst="roundRect">
-            <a:avLst/>
-          </a:prstGeom>
-          <a:solidFill>
-            <a:srgbClr val="5E6873"/>
-          </a:solidFill>
-          <a:ln>
-            <a:noFill/>
-          </a:ln>
-        </p:spPr>
-        <p:style>
-          <a:lnRef idx="1">
-            <a:schemeClr val="accent1"/>
-          </a:lnRef>
-          <a:fillRef idx="3">
-            <a:schemeClr val="accent1"/>
-          </a:fillRef>
-          <a:effectRef idx="2">
-            <a:schemeClr val="accent1"/>
-          </a:effectRef>
-          <a:fontRef idx="minor">
-            <a:schemeClr val="lt1"/>
-          </a:fontRef>
-        </p:style>
-        <p:txBody>
-          <a:bodyPr rtlCol="0" anchor="ctr"/>
-          <a:lstStyle/>
-          <a:p>
-            <a:pPr algn="ctr"/>
-          </a:p>
-        </p:txBody>
-      </p:sp>
-      <p:sp>
-        <p:nvSpPr>
-          <p:cNvPr id="24" name="Text: 04  三者比較"/>
-          <p:cNvSpPr txBox="1"/>
-          <p:nvPr/>
-        </p:nvSpPr>
-        <p:spPr>
-          <a:xfrm>
-            <a:off x="1097280" y="3968495"/>
-            <a:ext cx="2834639" cy="347472"/>
-          </a:xfrm>
-          <a:prstGeom prst="rect">
-            <a:avLst/>
-          </a:prstGeom>
-          <a:noFill/>
-        </p:spPr>
-        <p:txBody>
-          <a:bodyPr wrap="square" lIns="18288" rIns="18288" tIns="18288" bIns="18288" anchor="t">
-            <a:spAutoFit/>
-          </a:bodyPr>
-          <a:lstStyle/>
-          <a:p>
-            <a:pPr algn="l">
-              <a:spcAft>
-                <a:spcPts val="0"/>
-              </a:spcAft>
-            </a:pPr>
-            <a:r>
-              <a:rPr sz="1550" b="1" lang="ja-JP">
-                <a:solidFill>
-                  <a:srgbClr val="5E6873"/>
-                </a:solidFill>
-                <a:latin typeface="Noto Sans JP"/>
-                <a:ea typeface="Noto Sans JP"/>
-              </a:rPr>
-              <a:t>04  三者比較</a:t>
-            </a:r>
-          </a:p>
-        </p:txBody>
-      </p:sp>
-      <p:sp>
-        <p:nvSpPr>
-          <p:cNvPr id="25" name="Text: Plan／Previous／Current"/>
-          <p:cNvSpPr txBox="1"/>
-          <p:nvPr/>
-        </p:nvSpPr>
-        <p:spPr>
-          <a:xfrm>
-            <a:off x="1097280" y="4370831"/>
-            <a:ext cx="2834639" cy="384048"/>
-          </a:xfrm>
-          <a:prstGeom prst="rect">
-            <a:avLst/>
-          </a:prstGeom>
-          <a:noFill/>
-        </p:spPr>
-        <p:txBody>
-          <a:bodyPr wrap="square" lIns="18288" rIns="18288" tIns="18288" bIns="18288" anchor="t">
-            <a:spAutoFit/>
-          </a:bodyPr>
-          <a:lstStyle/>
-          <a:p>
-            <a:pPr algn="l">
-              <a:spcAft>
-                <a:spcPts val="0"/>
-              </a:spcAft>
-            </a:pPr>
-            <a:r>
-              <a:rPr sz="1400" b="0" lang="ja-JP">
-                <a:solidFill>
-                  <a:srgbClr val="13202B"/>
-                </a:solidFill>
-                <a:latin typeface="Noto Sans JP"/>
-                <a:ea typeface="Noto Sans JP"/>
-              </a:rPr>
-              <a:t>Plan／Previous／Current</a:t>
-            </a:r>
-          </a:p>
-        </p:txBody>
-      </p:sp>
-      <p:sp>
-        <p:nvSpPr>
-          <p:cNvPr id="26" name="構想・未実装" title="構想・未実装" descr="構想・未実装"/>
-          <p:cNvSpPr/>
-          <p:nvPr/>
-        </p:nvSpPr>
-        <p:spPr>
-          <a:xfrm>
-            <a:off x="2578608" y="3721607"/>
-            <a:ext cx="1481328" cy="237744"/>
-          </a:xfrm>
-          <a:prstGeom prst="roundRect">
-            <a:avLst/>
-          </a:prstGeom>
-          <a:solidFill>
-            <a:srgbClr val="F5E4D4"/>
-          </a:solidFill>
-          <a:ln w="8890">
-            <a:solidFill>
-              <a:srgbClr val="8C450E"/>
-            </a:solidFill>
-          </a:ln>
-        </p:spPr>
-        <p:style>
-          <a:lnRef idx="1">
-            <a:schemeClr val="accent1"/>
-          </a:lnRef>
-          <a:fillRef idx="3">
-            <a:schemeClr val="accent1"/>
-          </a:fillRef>
-          <a:effectRef idx="2">
-            <a:schemeClr val="accent1"/>
-          </a:effectRef>
-          <a:fontRef idx="minor">
-            <a:schemeClr val="lt1"/>
-          </a:fontRef>
-        </p:style>
-        <p:txBody>
-          <a:bodyPr rtlCol="0" anchor="ctr" lIns="0" rIns="0" tIns="0" bIns="0"/>
-          <a:lstStyle/>
-          <a:p>
-            <a:pPr algn="ctr"/>
-            <a:r>
-              <a:rPr sz="1050" b="1" lang="ja-JP">
-                <a:solidFill>
-                  <a:srgbClr val="8C450E"/>
-                </a:solidFill>
-                <a:latin typeface="Noto Sans JP"/>
-                <a:ea typeface="Noto Sans JP"/>
-              </a:rPr>
-              <a:t>構想・未実装</a:t>
-            </a:r>
-          </a:p>
-        </p:txBody>
-      </p:sp>
-      <p:sp>
-        <p:nvSpPr>
-          <p:cNvPr id="27" name="Card: 05  人が判断">
-            <a:extLst>
-              <a:ext uri="{C183D7F6-B498-43B3-948B-1728B52AA6E4}">
-                <adec:decorative xmlns:adec="http://schemas.microsoft.com/office/drawing/2017/decorative" val="1"/>
-              </a:ext>
-            </a:extLst>
-          </p:cNvPr>
-          <p:cNvSpPr/>
-          <p:nvPr/>
-        </p:nvSpPr>
-        <p:spPr>
-          <a:xfrm>
-            <a:off x="4407407" y="3840479"/>
-            <a:ext cx="3456432" cy="1024128"/>
-          </a:xfrm>
-          <a:prstGeom prst="roundRect">
-            <a:avLst/>
-          </a:prstGeom>
-          <a:solidFill>
-            <a:srgbClr val="FFFFFF"/>
-          </a:solidFill>
-          <a:ln w="10160">
-            <a:solidFill>
-              <a:srgbClr val="7B858A"/>
-            </a:solidFill>
-          </a:ln>
-        </p:spPr>
-        <p:style>
-          <a:lnRef idx="1">
-            <a:schemeClr val="accent1"/>
-          </a:lnRef>
-          <a:fillRef idx="3">
-            <a:schemeClr val="accent1"/>
-          </a:fillRef>
-          <a:effectRef idx="2">
-            <a:schemeClr val="accent1"/>
-          </a:effectRef>
-          <a:fontRef idx="minor">
-            <a:schemeClr val="lt1"/>
-          </a:fontRef>
-        </p:style>
-        <p:txBody>
-          <a:bodyPr rtlCol="0" anchor="ctr"/>
-          <a:lstStyle/>
-          <a:p>
-            <a:pPr algn="ctr"/>
-          </a:p>
-        </p:txBody>
-      </p:sp>
-      <p:sp>
-        <p:nvSpPr>
           <p:cNvPr id="28" name="Accent: 05  人が判断">
             <a:extLst>
               <a:ext uri="{C183D7F6-B498-43B3-948B-1728B52AA6E4}">
@@ -6402,7 +6402,7 @@
       </p:sp>
       <p:sp>
         <p:nvSpPr>
-          <p:cNvPr id="30" name="Text: 採用／是正／保留／不明"/>
+          <p:cNvPr id="30" name="Text: Adopt／Reject／Defer"/>
           <p:cNvSpPr txBox="1"/>
           <p:nvPr/>
         </p:nvSpPr>
@@ -6435,7 +6435,7 @@
                 <a:latin typeface="Noto Sans JP"/>
                 <a:ea typeface="Noto Sans JP"/>
               </a:rPr>
-              <a:t>採用／是正／保留／不明</a:t>
+              <a:t>Adopt／Reject／Defer</a:t>
             </a:r>
           </a:p>
         </p:txBody>
@@ -14270,56 +14270,7 @@
       </p:sp>
       <p:sp>
         <p:nvSpPr>
-          <p:cNvPr id="29" name="Chevron 28">
-            <a:extLst>
-              <a:ext uri="{C183D7F6-B498-43B3-948B-1728B52AA6E4}">
-                <adec:decorative xmlns:adec="http://schemas.microsoft.com/office/drawing/2017/decorative" val="1"/>
-              </a:ext>
-            </a:extLst>
-          </p:cNvPr>
-          <p:cNvSpPr/>
-          <p:nvPr/>
-        </p:nvSpPr>
-        <p:spPr>
-          <a:xfrm>
-            <a:off x="8503920" y="3429000"/>
-            <a:ext cx="310896" cy="384048"/>
-          </a:xfrm>
-          <a:prstGeom prst="chevron">
-            <a:avLst/>
-          </a:prstGeom>
-          <a:solidFill>
-            <a:srgbClr val="7B858A"/>
-          </a:solidFill>
-          <a:ln>
-            <a:noFill/>
-          </a:ln>
-        </p:spPr>
-        <p:style>
-          <a:lnRef idx="1">
-            <a:schemeClr val="accent1"/>
-          </a:lnRef>
-          <a:fillRef idx="3">
-            <a:schemeClr val="accent1"/>
-          </a:fillRef>
-          <a:effectRef idx="2">
-            <a:schemeClr val="accent1"/>
-          </a:effectRef>
-          <a:fontRef idx="minor">
-            <a:schemeClr val="lt1"/>
-          </a:fontRef>
-        </p:style>
-        <p:txBody>
-          <a:bodyPr rtlCol="0" anchor="ctr"/>
-          <a:lstStyle/>
-          <a:p>
-            <a:pPr algn="ctr"/>
-          </a:p>
-        </p:txBody>
-      </p:sp>
-      <p:sp>
-        <p:nvSpPr>
-          <p:cNvPr id="30" name="Card: creator-report">
+          <p:cNvPr id="29" name="Card: creator-report">
             <a:extLst>
               <a:ext uri="{C183D7F6-B498-43B3-948B-1728B52AA6E4}">
                 <adec:decorative xmlns:adec="http://schemas.microsoft.com/office/drawing/2017/decorative" val="1"/>
@@ -14370,7 +14321,7 @@
       </p:sp>
       <p:sp>
         <p:nvSpPr>
-          <p:cNvPr id="31" name="Accent: creator-report">
+          <p:cNvPr id="30" name="Accent: creator-report">
             <a:extLst>
               <a:ext uri="{C183D7F6-B498-43B3-948B-1728B52AA6E4}">
                 <adec:decorative xmlns:adec="http://schemas.microsoft.com/office/drawing/2017/decorative" val="1"/>
@@ -14419,7 +14370,7 @@
       </p:sp>
       <p:sp>
         <p:nvSpPr>
-          <p:cNvPr id="32" name="Text: creator-report"/>
+          <p:cNvPr id="31" name="Text: creator-report"/>
           <p:cNvSpPr txBox="1"/>
           <p:nvPr/>
         </p:nvSpPr>
@@ -14459,7 +14410,7 @@
       </p:sp>
       <p:sp>
         <p:nvSpPr>
-          <p:cNvPr id="33" name="Text: CLI出力"/>
+          <p:cNvPr id="32" name="Text: CLI出力"/>
           <p:cNvSpPr txBox="1"/>
           <p:nvPr/>
         </p:nvSpPr>
@@ -14499,7 +14450,7 @@
       </p:sp>
       <p:sp>
         <p:nvSpPr>
-          <p:cNvPr id="34" name="Card: localhost UI">
+          <p:cNvPr id="33" name="Card: localhost UI">
             <a:extLst>
               <a:ext uri="{C183D7F6-B498-43B3-948B-1728B52AA6E4}">
                 <adec:decorative xmlns:adec="http://schemas.microsoft.com/office/drawing/2017/decorative" val="1"/>
@@ -14550,7 +14501,7 @@
       </p:sp>
       <p:sp>
         <p:nvSpPr>
-          <p:cNvPr id="35" name="Accent: localhost UI">
+          <p:cNvPr id="34" name="Accent: localhost UI">
             <a:extLst>
               <a:ext uri="{C183D7F6-B498-43B3-948B-1728B52AA6E4}">
                 <adec:decorative xmlns:adec="http://schemas.microsoft.com/office/drawing/2017/decorative" val="1"/>
@@ -14599,7 +14550,7 @@
       </p:sp>
       <p:sp>
         <p:nvSpPr>
-          <p:cNvPr id="36" name="Text: localhost UI"/>
+          <p:cNvPr id="35" name="Text: localhost UI"/>
           <p:cNvSpPr txBox="1"/>
           <p:nvPr/>
         </p:nvSpPr>
@@ -14639,7 +14590,7 @@
       </p:sp>
       <p:sp>
         <p:nvSpPr>
-          <p:cNvPr id="37" name="Text: pending／完了画面"/>
+          <p:cNvPr id="36" name="Text: pending／完了画面"/>
           <p:cNvSpPr txBox="1"/>
           <p:nvPr/>
         </p:nvSpPr>
@@ -14679,7 +14630,7 @@
       </p:sp>
       <p:sp>
         <p:nvSpPr>
-          <p:cNvPr id="38" name="Card: publication view">
+          <p:cNvPr id="37" name="Card: publication view">
             <a:extLst>
               <a:ext uri="{C183D7F6-B498-43B3-948B-1728B52AA6E4}">
                 <adec:decorative xmlns:adec="http://schemas.microsoft.com/office/drawing/2017/decorative" val="1"/>
@@ -14730,7 +14681,7 @@
       </p:sp>
       <p:sp>
         <p:nvSpPr>
-          <p:cNvPr id="39" name="Accent: publication view">
+          <p:cNvPr id="38" name="Accent: publication view">
             <a:extLst>
               <a:ext uri="{C183D7F6-B498-43B3-948B-1728B52AA6E4}">
                 <adec:decorative xmlns:adec="http://schemas.microsoft.com/office/drawing/2017/decorative" val="1"/>
@@ -14779,7 +14730,7 @@
       </p:sp>
       <p:sp>
         <p:nvSpPr>
-          <p:cNvPr id="40" name="Text: publication view"/>
+          <p:cNvPr id="39" name="Text: publication view"/>
           <p:cNvSpPr txBox="1"/>
           <p:nvPr/>
         </p:nvSpPr>
@@ -14819,7 +14770,7 @@
       </p:sp>
       <p:sp>
         <p:nvSpPr>
-          <p:cNvPr id="41" name="Text: ローカル生成のみ"/>
+          <p:cNvPr id="40" name="Text: ローカル生成のみ"/>
           <p:cNvSpPr txBox="1"/>
           <p:nvPr/>
         </p:nvSpPr>
@@ -14857,6 +14808,47 @@
           </a:p>
         </p:txBody>
       </p:sp>
+      <p:cxnSp>
+        <p:nvCxnSpPr>
+          <p:cNvPr id="41" name="Connector 40">
+            <a:extLst>
+              <a:ext uri="{C183D7F6-B498-43B3-948B-1728B52AA6E4}">
+                <adec:decorative xmlns:adec="http://schemas.microsoft.com/office/drawing/2017/decorative" val="1"/>
+              </a:ext>
+            </a:extLst>
+          </p:cNvPr>
+          <p:cNvCxnSpPr/>
+          <p:nvPr/>
+        </p:nvCxnSpPr>
+        <p:spPr>
+          <a:xfrm flipV="1">
+            <a:off x="8375904" y="2034540"/>
+            <a:ext cx="585216" cy="1581912"/>
+          </a:xfrm>
+          <a:prstGeom prst="line">
+            <a:avLst/>
+          </a:prstGeom>
+          <a:ln w="17780">
+            <a:solidFill>
+              <a:srgbClr val="7B858A"/>
+            </a:solidFill>
+          </a:ln>
+        </p:spPr>
+        <p:style>
+          <a:lnRef idx="2">
+            <a:schemeClr val="accent1"/>
+          </a:lnRef>
+          <a:fillRef idx="0">
+            <a:schemeClr val="accent1"/>
+          </a:fillRef>
+          <a:effectRef idx="1">
+            <a:schemeClr val="accent1"/>
+          </a:effectRef>
+          <a:fontRef idx="minor">
+            <a:schemeClr val="tx1"/>
+          </a:fontRef>
+        </p:style>
+      </p:cxnSp>
       <p:cxnSp>
         <p:nvCxnSpPr>
           <p:cNvPr id="42" name="Connector 41">
@@ -14871,8 +14863,8 @@
         </p:nvCxnSpPr>
         <p:spPr>
           <a:xfrm flipV="1">
-            <a:off x="8375904" y="2034540"/>
-            <a:ext cx="585216" cy="1581912"/>
+            <a:off x="8375904" y="3012948"/>
+            <a:ext cx="585216" cy="603504"/>
           </a:xfrm>
           <a:prstGeom prst="line">
             <a:avLst/>
@@ -14911,9 +14903,9 @@
           <p:nvPr/>
         </p:nvCxnSpPr>
         <p:spPr>
-          <a:xfrm flipV="1">
-            <a:off x="8375904" y="3012948"/>
-            <a:ext cx="585216" cy="603504"/>
+          <a:xfrm>
+            <a:off x="8375904" y="3616452"/>
+            <a:ext cx="585216" cy="374904"/>
           </a:xfrm>
           <a:prstGeom prst="line">
             <a:avLst/>
@@ -14939,50 +14931,9 @@
           </a:fontRef>
         </p:style>
       </p:cxnSp>
-      <p:cxnSp>
-        <p:nvCxnSpPr>
-          <p:cNvPr id="44" name="Connector 43">
-            <a:extLst>
-              <a:ext uri="{C183D7F6-B498-43B3-948B-1728B52AA6E4}">
-                <adec:decorative xmlns:adec="http://schemas.microsoft.com/office/drawing/2017/decorative" val="1"/>
-              </a:ext>
-            </a:extLst>
-          </p:cNvPr>
-          <p:cNvCxnSpPr/>
-          <p:nvPr/>
-        </p:nvCxnSpPr>
-        <p:spPr>
-          <a:xfrm>
-            <a:off x="8375904" y="3616452"/>
-            <a:ext cx="585216" cy="374904"/>
-          </a:xfrm>
-          <a:prstGeom prst="line">
-            <a:avLst/>
-          </a:prstGeom>
-          <a:ln w="17780">
-            <a:solidFill>
-              <a:srgbClr val="7B858A"/>
-            </a:solidFill>
-          </a:ln>
-        </p:spPr>
-        <p:style>
-          <a:lnRef idx="2">
-            <a:schemeClr val="accent1"/>
-          </a:lnRef>
-          <a:fillRef idx="0">
-            <a:schemeClr val="accent1"/>
-          </a:fillRef>
-          <a:effectRef idx="1">
-            <a:schemeClr val="accent1"/>
-          </a:effectRef>
-          <a:fontRef idx="minor">
-            <a:schemeClr val="tx1"/>
-          </a:fontRef>
-        </p:style>
-      </p:cxnSp>
-      <p:sp>
-        <p:nvSpPr>
-          <p:cNvPr id="45" name="Rounded Rectangle 44">
+      <p:sp>
+        <p:nvSpPr>
+          <p:cNvPr id="44" name="Rounded Rectangle 43">
             <a:extLst>
               <a:ext uri="{C183D7F6-B498-43B3-948B-1728B52AA6E4}">
                 <adec:decorative xmlns:adec="http://schemas.microsoft.com/office/drawing/2017/decorative" val="1"/>
@@ -15033,7 +14984,7 @@
       </p:sp>
       <p:sp>
         <p:nvSpPr>
-          <p:cNvPr id="46" name="TextBox 45"/>
+          <p:cNvPr id="45" name="TextBox 44"/>
           <p:cNvSpPr txBox="1"/>
           <p:nvPr/>
         </p:nvSpPr>
@@ -15121,7 +15072,7 @@
       </p:sp>
       <p:sp>
         <p:nvSpPr>
-          <p:cNvPr id="47" name="Text: しないこと：AIの自動実行・自動採否／画像の意味"/>
+          <p:cNvPr id="46" name="Text: しないこと：AIの自動実行・自動採否／画像の意味"/>
           <p:cNvSpPr txBox="1"/>
           <p:nvPr/>
         </p:nvSpPr>
@@ -15161,7 +15112,7 @@
       </p:sp>
       <p:sp>
         <p:nvSpPr>
-          <p:cNvPr id="48" name="Text: 詳しい手順: 15分 壁画tutorial"/>
+          <p:cNvPr id="47" name="Text: 詳しい手順: 15分 壁画tutorial"/>
           <p:cNvSpPr txBox="1"/>
           <p:nvPr/>
         </p:nvSpPr>
@@ -15202,7 +15153,7 @@
       </p:sp>
       <p:cxnSp>
         <p:nvCxnSpPr>
-          <p:cNvPr id="49" name="Connector 48">
+          <p:cNvPr id="48" name="Connector 47">
             <a:extLst>
               <a:ext uri="{C183D7F6-B498-43B3-948B-1728B52AA6E4}">
                 <adec:decorative xmlns:adec="http://schemas.microsoft.com/office/drawing/2017/decorative" val="1"/>
@@ -15243,7 +15194,7 @@
       </p:cxnSp>
       <p:sp>
         <p:nvSpPr>
-          <p:cNvPr id="50" name="Text: Concept · v0.9.0 · 確認日 2"/>
+          <p:cNvPr id="49" name="Text: Concept · v0.9.0 · 確認日 2"/>
           <p:cNvSpPr txBox="1"/>
           <p:nvPr/>
         </p:nvSpPr>
@@ -15284,7 +15235,7 @@
       </p:sp>
       <p:sp>
         <p:nvSpPr>
-          <p:cNvPr id="51" name="Text: Creator workflow §§1-3 ·"/>
+          <p:cNvPr id="50" name="Text: Creator workflow §§1-3 ·"/>
           <p:cNvSpPr txBox="1"/>
           <p:nvPr/>
         </p:nvSpPr>
@@ -15324,7 +15275,7 @@
       </p:sp>
       <p:sp>
         <p:nvSpPr>
-          <p:cNvPr id="52" name="Text: 04"/>
+          <p:cNvPr id="51" name="Text: 04"/>
           <p:cNvSpPr txBox="1"/>
           <p:nvPr/>
         </p:nvSpPr>

</xml_diff>